<commit_message>
docs: polish project status slide layout
Co-authored-by: 程序员鱼皮 <592789970@qq.com>
</commit_message>
<xml_diff>
--- a/docs/reports/project-status-2026-07-16.pptx
+++ b/docs/reports/project-status-2026-07-16.pptx
@@ -2111,6 +2111,10 @@
             <a:prstDash val="solid"/>
           </a:ln>
         </p:spPr>
+        <p:txBody>
+          <a:bodyPr/>
+          <a:p/>
+        </p:txBody>
       </p:sp>
       <p:sp>
         <p:nvSpPr>
@@ -2140,6 +2144,10 @@
             <a:prstDash val="solid"/>
           </a:ln>
         </p:spPr>
+        <p:txBody>
+          <a:bodyPr/>
+          <a:p/>
+        </p:txBody>
       </p:sp>
       <p:sp>
         <p:nvSpPr>
@@ -2165,6 +2173,10 @@
             <a:prstDash val="solid"/>
           </a:ln>
         </p:spPr>
+        <p:txBody>
+          <a:bodyPr/>
+          <a:p/>
+        </p:txBody>
       </p:sp>
       <p:sp>
         <p:nvSpPr>
@@ -2192,6 +2204,10 @@
             <a:prstDash val="solid"/>
           </a:ln>
         </p:spPr>
+        <p:txBody>
+          <a:bodyPr/>
+          <a:p/>
+        </p:txBody>
       </p:sp>
       <p:sp>
         <p:nvSpPr>
@@ -2318,6 +2334,10 @@
             <a:prstDash val="solid"/>
           </a:ln>
         </p:spPr>
+        <p:txBody>
+          <a:bodyPr/>
+          <a:p/>
+        </p:txBody>
       </p:sp>
       <p:sp>
         <p:nvSpPr>
@@ -2405,8 +2425,8 @@
         </p:nvSpPr>
         <p:spPr>
           <a:xfrm>
-            <a:off x="941832" y="4590288"/>
-            <a:ext cx="2240280" cy="338328"/>
+            <a:off x="868680" y="4590288"/>
+            <a:ext cx="2423160" cy="338328"/>
           </a:xfrm>
           <a:prstGeom prst="rect">
             <a:avLst/>
@@ -2424,9 +2444,9 @@
               <a:buNone/>
             </a:pPr>
             <a:r>
-              <a:rPr lang="en-US" sz="1350" dirty="0">
-                <a:solidFill>
-                  <a:srgbClr val="7FDBDA"/>
+              <a:rPr lang="en-US" sz="1250" dirty="0">
+                <a:solidFill>
+                  <a:srgbClr val="FFFFFF"/>
                 </a:solidFill>
                 <a:latin typeface="Noto Sans CJK SC" pitchFamily="34" charset="0"/>
                 <a:ea typeface="Noto Sans CJK SC" pitchFamily="34" charset="-122"/>
@@ -2468,6 +2488,10 @@
             <a:prstDash val="solid"/>
           </a:ln>
         </p:spPr>
+        <p:txBody>
+          <a:bodyPr/>
+          <a:p/>
+        </p:txBody>
       </p:sp>
       <p:sp>
         <p:nvSpPr>
@@ -2555,8 +2579,8 @@
         </p:nvSpPr>
         <p:spPr>
           <a:xfrm>
-            <a:off x="3931920" y="4590288"/>
-            <a:ext cx="2240280" cy="338328"/>
+            <a:off x="3858768" y="4590288"/>
+            <a:ext cx="2423160" cy="338328"/>
           </a:xfrm>
           <a:prstGeom prst="rect">
             <a:avLst/>
@@ -2574,9 +2598,9 @@
               <a:buNone/>
             </a:pPr>
             <a:r>
-              <a:rPr lang="en-US" sz="1350" dirty="0">
-                <a:solidFill>
-                  <a:srgbClr val="7FDBDA"/>
+              <a:rPr lang="en-US" sz="1250" dirty="0">
+                <a:solidFill>
+                  <a:srgbClr val="FFFFFF"/>
                 </a:solidFill>
                 <a:latin typeface="Noto Sans CJK SC" pitchFamily="34" charset="0"/>
                 <a:ea typeface="Noto Sans CJK SC" pitchFamily="34" charset="-122"/>
@@ -2616,6 +2640,10 @@
             <a:prstDash val="solid"/>
           </a:ln>
         </p:spPr>
+        <p:txBody>
+          <a:bodyPr/>
+          <a:p/>
+        </p:txBody>
       </p:sp>
       <p:sp>
         <p:nvSpPr>
@@ -2703,8 +2731,8 @@
         </p:nvSpPr>
         <p:spPr>
           <a:xfrm>
-            <a:off x="6922008" y="4590288"/>
-            <a:ext cx="2240280" cy="338328"/>
+            <a:off x="6848856" y="4590288"/>
+            <a:ext cx="2423160" cy="338328"/>
           </a:xfrm>
           <a:prstGeom prst="rect">
             <a:avLst/>
@@ -2722,9 +2750,9 @@
               <a:buNone/>
             </a:pPr>
             <a:r>
-              <a:rPr lang="en-US" sz="1350" dirty="0">
-                <a:solidFill>
-                  <a:srgbClr val="7FDBDA"/>
+              <a:rPr lang="en-US" sz="1250" dirty="0">
+                <a:solidFill>
+                  <a:srgbClr val="FFFFFF"/>
                 </a:solidFill>
                 <a:latin typeface="Noto Sans CJK SC" pitchFamily="34" charset="0"/>
                 <a:ea typeface="Noto Sans CJK SC" pitchFamily="34" charset="-122"/>
@@ -2761,9 +2789,9 @@
               <a:buNone/>
             </a:pPr>
             <a:r>
-              <a:rPr lang="en-US" sz="1050" dirty="0">
-                <a:solidFill>
-                  <a:srgbClr val="9BDDD7"/>
+              <a:rPr lang="en-US" sz="1100" dirty="0">
+                <a:solidFill>
+                  <a:srgbClr val="BDEAE6"/>
                 </a:solidFill>
                 <a:latin typeface="Noto Sans CJK SC" pitchFamily="34" charset="0"/>
                 <a:ea typeface="Noto Sans CJK SC" pitchFamily="34" charset="-122"/>
@@ -2835,6 +2863,10 @@
             <a:prstDash val="solid"/>
           </a:ln>
         </p:spPr>
+        <p:txBody>
+          <a:bodyPr/>
+          <a:p/>
+        </p:txBody>
       </p:sp>
       <p:sp>
         <p:nvSpPr>
@@ -2864,6 +2896,10 @@
             <a:prstDash val="solid"/>
           </a:ln>
         </p:spPr>
+        <p:txBody>
+          <a:bodyPr/>
+          <a:p/>
+        </p:txBody>
       </p:sp>
       <p:sp>
         <p:nvSpPr>
@@ -2970,7 +3006,7 @@
             <a:r>
               <a:rPr lang="en-US" sz="950" dirty="0">
                 <a:solidFill>
-                  <a:srgbClr val="5E7680"/>
+                  <a:srgbClr val="425B65"/>
                 </a:solidFill>
                 <a:latin typeface="Calibri" pitchFamily="34" charset="0"/>
                 <a:ea typeface="Calibri" pitchFamily="34" charset="-122"/>
@@ -3015,6 +3051,10 @@
             </a:outerShdw>
           </a:effectLst>
         </p:spPr>
+        <p:txBody>
+          <a:bodyPr/>
+          <a:p/>
+        </p:txBody>
       </p:sp>
       <p:sp>
         <p:nvSpPr>
@@ -3040,6 +3080,10 @@
             <a:prstDash val="solid"/>
           </a:ln>
         </p:spPr>
+        <p:txBody>
+          <a:bodyPr/>
+          <a:p/>
+        </p:txBody>
       </p:sp>
       <p:sp>
         <p:nvSpPr>
@@ -3146,7 +3190,7 @@
             <a:r>
               <a:rPr lang="en-US" sz="1050" dirty="0">
                 <a:solidFill>
-                  <a:srgbClr val="5E7680"/>
+                  <a:srgbClr val="425B65"/>
                 </a:solidFill>
                 <a:latin typeface="Noto Sans CJK SC" pitchFamily="34" charset="0"/>
                 <a:ea typeface="Noto Sans CJK SC" pitchFamily="34" charset="-122"/>
@@ -3191,6 +3235,10 @@
             </a:outerShdw>
           </a:effectLst>
         </p:spPr>
+        <p:txBody>
+          <a:bodyPr/>
+          <a:p/>
+        </p:txBody>
       </p:sp>
       <p:sp>
         <p:nvSpPr>
@@ -3216,6 +3264,10 @@
             <a:prstDash val="solid"/>
           </a:ln>
         </p:spPr>
+        <p:txBody>
+          <a:bodyPr/>
+          <a:p/>
+        </p:txBody>
       </p:sp>
       <p:sp>
         <p:nvSpPr>
@@ -3322,7 +3374,7 @@
             <a:r>
               <a:rPr lang="en-US" sz="1050" dirty="0">
                 <a:solidFill>
-                  <a:srgbClr val="5E7680"/>
+                  <a:srgbClr val="425B65"/>
                 </a:solidFill>
                 <a:latin typeface="Noto Sans CJK SC" pitchFamily="34" charset="0"/>
                 <a:ea typeface="Noto Sans CJK SC" pitchFamily="34" charset="-122"/>
@@ -3367,6 +3419,10 @@
             </a:outerShdw>
           </a:effectLst>
         </p:spPr>
+        <p:txBody>
+          <a:bodyPr/>
+          <a:p/>
+        </p:txBody>
       </p:sp>
       <p:sp>
         <p:nvSpPr>
@@ -3392,6 +3448,10 @@
             <a:prstDash val="solid"/>
           </a:ln>
         </p:spPr>
+        <p:txBody>
+          <a:bodyPr/>
+          <a:p/>
+        </p:txBody>
       </p:sp>
       <p:sp>
         <p:nvSpPr>
@@ -3498,7 +3558,7 @@
             <a:r>
               <a:rPr lang="en-US" sz="1050" dirty="0">
                 <a:solidFill>
-                  <a:srgbClr val="5E7680"/>
+                  <a:srgbClr val="425B65"/>
                 </a:solidFill>
                 <a:latin typeface="Noto Sans CJK SC" pitchFamily="34" charset="0"/>
                 <a:ea typeface="Noto Sans CJK SC" pitchFamily="34" charset="-122"/>
@@ -3543,6 +3603,10 @@
             </a:outerShdw>
           </a:effectLst>
         </p:spPr>
+        <p:txBody>
+          <a:bodyPr/>
+          <a:p/>
+        </p:txBody>
       </p:sp>
       <p:sp>
         <p:nvSpPr>
@@ -3568,6 +3632,10 @@
             <a:prstDash val="solid"/>
           </a:ln>
         </p:spPr>
+        <p:txBody>
+          <a:bodyPr/>
+          <a:p/>
+        </p:txBody>
       </p:sp>
       <p:sp>
         <p:nvSpPr>
@@ -3674,7 +3742,7 @@
             <a:r>
               <a:rPr lang="en-US" sz="1050" dirty="0">
                 <a:solidFill>
-                  <a:srgbClr val="5E7680"/>
+                  <a:srgbClr val="425B65"/>
                 </a:solidFill>
                 <a:latin typeface="Noto Sans CJK SC" pitchFamily="34" charset="0"/>
                 <a:ea typeface="Noto Sans CJK SC" pitchFamily="34" charset="-122"/>
@@ -3712,6 +3780,10 @@
             <a:prstDash val="solid"/>
           </a:ln>
         </p:spPr>
+        <p:txBody>
+          <a:bodyPr/>
+          <a:p/>
+        </p:txBody>
       </p:sp>
       <p:sp>
         <p:nvSpPr>
@@ -3856,6 +3928,10 @@
             <a:prstDash val="solid"/>
           </a:ln>
         </p:spPr>
+        <p:txBody>
+          <a:bodyPr/>
+          <a:p/>
+        </p:txBody>
       </p:sp>
       <p:sp>
         <p:nvSpPr>
@@ -3956,6 +4032,10 @@
             <a:prstDash val="solid"/>
           </a:ln>
         </p:spPr>
+        <p:txBody>
+          <a:bodyPr/>
+          <a:p/>
+        </p:txBody>
       </p:sp>
       <p:sp>
         <p:nvSpPr>
@@ -3985,6 +4065,10 @@
             <a:prstDash val="solid"/>
           </a:ln>
         </p:spPr>
+        <p:txBody>
+          <a:bodyPr/>
+          <a:p/>
+        </p:txBody>
       </p:sp>
       <p:sp>
         <p:nvSpPr>
@@ -4091,7 +4175,7 @@
             <a:r>
               <a:rPr lang="en-US" sz="950" dirty="0">
                 <a:solidFill>
-                  <a:srgbClr val="5E7680"/>
+                  <a:srgbClr val="425B65"/>
                 </a:solidFill>
                 <a:latin typeface="Calibri" pitchFamily="34" charset="0"/>
                 <a:ea typeface="Calibri" pitchFamily="34" charset="-122"/>
@@ -4136,6 +4220,10 @@
             </a:outerShdw>
           </a:effectLst>
         </p:spPr>
+        <p:txBody>
+          <a:bodyPr/>
+          <a:p/>
+        </p:txBody>
       </p:sp>
       <p:sp>
         <p:nvSpPr>
@@ -4163,6 +4251,10 @@
             <a:prstDash val="solid"/>
           </a:ln>
         </p:spPr>
+        <p:txBody>
+          <a:bodyPr/>
+          <a:p/>
+        </p:txBody>
       </p:sp>
       <p:sp>
         <p:nvSpPr>
@@ -4310,7 +4402,7 @@
             <a:r>
               <a:rPr lang="en-US" sz="1400" dirty="0">
                 <a:solidFill>
-                  <a:srgbClr val="5E7680"/>
+                  <a:srgbClr val="425B65"/>
                 </a:solidFill>
                 <a:latin typeface="Noto Sans CJK SC" pitchFamily="34" charset="0"/>
                 <a:ea typeface="Noto Sans CJK SC" pitchFamily="34" charset="-122"/>
@@ -4355,6 +4447,10 @@
             </a:outerShdw>
           </a:effectLst>
         </p:spPr>
+        <p:txBody>
+          <a:bodyPr/>
+          <a:p/>
+        </p:txBody>
       </p:sp>
       <p:sp>
         <p:nvSpPr>
@@ -4382,6 +4478,10 @@
             <a:prstDash val="solid"/>
           </a:ln>
         </p:spPr>
+        <p:txBody>
+          <a:bodyPr/>
+          <a:p/>
+        </p:txBody>
       </p:sp>
       <p:sp>
         <p:nvSpPr>
@@ -4529,7 +4629,7 @@
             <a:r>
               <a:rPr lang="en-US" sz="1400" dirty="0">
                 <a:solidFill>
-                  <a:srgbClr val="5E7680"/>
+                  <a:srgbClr val="425B65"/>
                 </a:solidFill>
                 <a:latin typeface="Noto Sans CJK SC" pitchFamily="34" charset="0"/>
                 <a:ea typeface="Noto Sans CJK SC" pitchFamily="34" charset="-122"/>
@@ -4574,6 +4674,10 @@
             </a:outerShdw>
           </a:effectLst>
         </p:spPr>
+        <p:txBody>
+          <a:bodyPr/>
+          <a:p/>
+        </p:txBody>
       </p:sp>
       <p:sp>
         <p:nvSpPr>
@@ -4601,6 +4705,10 @@
             <a:prstDash val="solid"/>
           </a:ln>
         </p:spPr>
+        <p:txBody>
+          <a:bodyPr/>
+          <a:p/>
+        </p:txBody>
       </p:sp>
       <p:sp>
         <p:nvSpPr>
@@ -4748,7 +4856,7 @@
             <a:r>
               <a:rPr lang="en-US" sz="1400" dirty="0">
                 <a:solidFill>
-                  <a:srgbClr val="5E7680"/>
+                  <a:srgbClr val="425B65"/>
                 </a:solidFill>
                 <a:latin typeface="Noto Sans CJK SC" pitchFamily="34" charset="0"/>
                 <a:ea typeface="Noto Sans CJK SC" pitchFamily="34" charset="-122"/>
@@ -4784,6 +4892,10 @@
             <a:prstDash val="solid"/>
           </a:ln>
         </p:spPr>
+        <p:txBody>
+          <a:bodyPr/>
+          <a:p/>
+        </p:txBody>
       </p:sp>
       <p:sp>
         <p:nvSpPr>
@@ -4809,6 +4921,10 @@
             <a:prstDash val="solid"/>
           </a:ln>
         </p:spPr>
+        <p:txBody>
+          <a:bodyPr/>
+          <a:p/>
+        </p:txBody>
       </p:sp>
       <p:sp>
         <p:nvSpPr>
@@ -4836,6 +4952,10 @@
             <a:prstDash val="solid"/>
           </a:ln>
         </p:spPr>
+        <p:txBody>
+          <a:bodyPr/>
+          <a:p/>
+        </p:txBody>
       </p:sp>
       <p:sp>
         <p:nvSpPr>
@@ -4975,6 +5095,10 @@
             <a:prstDash val="solid"/>
           </a:ln>
         </p:spPr>
+        <p:txBody>
+          <a:bodyPr/>
+          <a:p/>
+        </p:txBody>
       </p:sp>
       <p:sp>
         <p:nvSpPr>
@@ -5004,6 +5128,10 @@
             <a:prstDash val="solid"/>
           </a:ln>
         </p:spPr>
+        <p:txBody>
+          <a:bodyPr/>
+          <a:p/>
+        </p:txBody>
       </p:sp>
       <p:sp>
         <p:nvSpPr>
@@ -5110,7 +5238,7 @@
             <a:r>
               <a:rPr lang="en-US" sz="950" dirty="0">
                 <a:solidFill>
-                  <a:srgbClr val="5E7680"/>
+                  <a:srgbClr val="425B65"/>
                 </a:solidFill>
                 <a:latin typeface="Calibri" pitchFamily="34" charset="0"/>
                 <a:ea typeface="Calibri" pitchFamily="34" charset="-122"/>
@@ -5155,6 +5283,10 @@
             </a:outerShdw>
           </a:effectLst>
         </p:spPr>
+        <p:txBody>
+          <a:bodyPr/>
+          <a:p/>
+        </p:txBody>
       </p:sp>
       <p:sp>
         <p:nvSpPr>
@@ -5182,6 +5314,10 @@
             <a:prstDash val="solid"/>
           </a:ln>
         </p:spPr>
+        <p:txBody>
+          <a:bodyPr/>
+          <a:p/>
+        </p:txBody>
       </p:sp>
       <p:sp>
         <p:nvSpPr>
@@ -5329,7 +5465,7 @@
             <a:r>
               <a:rPr lang="en-US" sz="1400" dirty="0">
                 <a:solidFill>
-                  <a:srgbClr val="5E7680"/>
+                  <a:srgbClr val="425B65"/>
                 </a:solidFill>
                 <a:latin typeface="Noto Sans CJK SC" pitchFamily="34" charset="0"/>
                 <a:ea typeface="Noto Sans CJK SC" pitchFamily="34" charset="-122"/>
@@ -5374,6 +5510,10 @@
             </a:outerShdw>
           </a:effectLst>
         </p:spPr>
+        <p:txBody>
+          <a:bodyPr/>
+          <a:p/>
+        </p:txBody>
       </p:sp>
       <p:sp>
         <p:nvSpPr>
@@ -5401,6 +5541,10 @@
             <a:prstDash val="solid"/>
           </a:ln>
         </p:spPr>
+        <p:txBody>
+          <a:bodyPr/>
+          <a:p/>
+        </p:txBody>
       </p:sp>
       <p:sp>
         <p:nvSpPr>
@@ -5548,7 +5692,7 @@
             <a:r>
               <a:rPr lang="en-US" sz="1400" dirty="0">
                 <a:solidFill>
-                  <a:srgbClr val="5E7680"/>
+                  <a:srgbClr val="425B65"/>
                 </a:solidFill>
                 <a:latin typeface="Noto Sans CJK SC" pitchFamily="34" charset="0"/>
                 <a:ea typeface="Noto Sans CJK SC" pitchFamily="34" charset="-122"/>
@@ -5593,6 +5737,10 @@
             </a:outerShdw>
           </a:effectLst>
         </p:spPr>
+        <p:txBody>
+          <a:bodyPr/>
+          <a:p/>
+        </p:txBody>
       </p:sp>
       <p:sp>
         <p:nvSpPr>
@@ -5620,6 +5768,10 @@
             <a:prstDash val="solid"/>
           </a:ln>
         </p:spPr>
+        <p:txBody>
+          <a:bodyPr/>
+          <a:p/>
+        </p:txBody>
       </p:sp>
       <p:sp>
         <p:nvSpPr>
@@ -5767,7 +5919,7 @@
             <a:r>
               <a:rPr lang="en-US" sz="1400" dirty="0">
                 <a:solidFill>
-                  <a:srgbClr val="5E7680"/>
+                  <a:srgbClr val="425B65"/>
                 </a:solidFill>
                 <a:latin typeface="Noto Sans CJK SC" pitchFamily="34" charset="0"/>
                 <a:ea typeface="Noto Sans CJK SC" pitchFamily="34" charset="-122"/>
@@ -5812,6 +5964,10 @@
             </a:outerShdw>
           </a:effectLst>
         </p:spPr>
+        <p:txBody>
+          <a:bodyPr/>
+          <a:p/>
+        </p:txBody>
       </p:sp>
       <p:sp>
         <p:nvSpPr>
@@ -5839,6 +5995,10 @@
             <a:prstDash val="solid"/>
           </a:ln>
         </p:spPr>
+        <p:txBody>
+          <a:bodyPr/>
+          <a:p/>
+        </p:txBody>
       </p:sp>
       <p:sp>
         <p:nvSpPr>
@@ -5986,7 +6146,7 @@
             <a:r>
               <a:rPr lang="en-US" sz="1400" dirty="0">
                 <a:solidFill>
-                  <a:srgbClr val="5E7680"/>
+                  <a:srgbClr val="425B65"/>
                 </a:solidFill>
                 <a:latin typeface="Noto Sans CJK SC" pitchFamily="34" charset="0"/>
                 <a:ea typeface="Noto Sans CJK SC" pitchFamily="34" charset="-122"/>
@@ -6058,6 +6218,10 @@
             <a:prstDash val="solid"/>
           </a:ln>
         </p:spPr>
+        <p:txBody>
+          <a:bodyPr/>
+          <a:p/>
+        </p:txBody>
       </p:sp>
       <p:sp>
         <p:nvSpPr>
@@ -6087,6 +6251,10 @@
             <a:prstDash val="solid"/>
           </a:ln>
         </p:spPr>
+        <p:txBody>
+          <a:bodyPr/>
+          <a:p/>
+        </p:txBody>
       </p:sp>
       <p:sp>
         <p:nvSpPr>
@@ -6193,7 +6361,7 @@
             <a:r>
               <a:rPr lang="en-US" sz="950" dirty="0">
                 <a:solidFill>
-                  <a:srgbClr val="5E7680"/>
+                  <a:srgbClr val="425B65"/>
                 </a:solidFill>
                 <a:latin typeface="Calibri" pitchFamily="34" charset="0"/>
                 <a:ea typeface="Calibri" pitchFamily="34" charset="-122"/>
@@ -6238,6 +6406,10 @@
             </a:outerShdw>
           </a:effectLst>
         </p:spPr>
+        <p:txBody>
+          <a:bodyPr/>
+          <a:p/>
+        </p:txBody>
       </p:sp>
       <p:sp>
         <p:nvSpPr>
@@ -6265,6 +6437,10 @@
             <a:prstDash val="solid"/>
           </a:ln>
         </p:spPr>
+        <p:txBody>
+          <a:bodyPr/>
+          <a:p/>
+        </p:txBody>
       </p:sp>
       <p:sp>
         <p:nvSpPr>
@@ -6377,6 +6553,10 @@
             </a:outerShdw>
           </a:effectLst>
         </p:spPr>
+        <p:txBody>
+          <a:bodyPr/>
+          <a:p/>
+        </p:txBody>
       </p:sp>
       <p:sp>
         <p:nvSpPr>
@@ -6404,6 +6584,10 @@
             <a:prstDash val="solid"/>
           </a:ln>
         </p:spPr>
+        <p:txBody>
+          <a:bodyPr/>
+          <a:p/>
+        </p:txBody>
       </p:sp>
       <p:sp>
         <p:nvSpPr>
@@ -6516,6 +6700,10 @@
             </a:outerShdw>
           </a:effectLst>
         </p:spPr>
+        <p:txBody>
+          <a:bodyPr/>
+          <a:p/>
+        </p:txBody>
       </p:sp>
       <p:sp>
         <p:nvSpPr>
@@ -6543,6 +6731,10 @@
             <a:prstDash val="solid"/>
           </a:ln>
         </p:spPr>
+        <p:txBody>
+          <a:bodyPr/>
+          <a:p/>
+        </p:txBody>
       </p:sp>
       <p:sp>
         <p:nvSpPr>
@@ -6655,6 +6847,10 @@
             </a:outerShdw>
           </a:effectLst>
         </p:spPr>
+        <p:txBody>
+          <a:bodyPr/>
+          <a:p/>
+        </p:txBody>
       </p:sp>
       <p:sp>
         <p:nvSpPr>
@@ -6682,6 +6878,10 @@
             <a:prstDash val="solid"/>
           </a:ln>
         </p:spPr>
+        <p:txBody>
+          <a:bodyPr/>
+          <a:p/>
+        </p:txBody>
       </p:sp>
       <p:sp>
         <p:nvSpPr>
@@ -6787,6 +6987,10 @@
             <a:prstDash val="solid"/>
           </a:ln>
         </p:spPr>
+        <p:txBody>
+          <a:bodyPr/>
+          <a:p/>
+        </p:txBody>
       </p:sp>
       <p:sp>
         <p:nvSpPr>
@@ -6851,6 +7055,10 @@
             <a:prstDash val="solid"/>
           </a:ln>
         </p:spPr>
+        <p:txBody>
+          <a:bodyPr/>
+          <a:p/>
+        </p:txBody>
       </p:sp>
       <p:sp>
         <p:nvSpPr>
@@ -6915,6 +7123,10 @@
             <a:prstDash val="solid"/>
           </a:ln>
         </p:spPr>
+        <p:txBody>
+          <a:bodyPr/>
+          <a:p/>
+        </p:txBody>
       </p:sp>
       <p:sp>
         <p:nvSpPr>
@@ -6979,6 +7191,10 @@
             <a:prstDash val="solid"/>
           </a:ln>
         </p:spPr>
+        <p:txBody>
+          <a:bodyPr/>
+          <a:p/>
+        </p:txBody>
       </p:sp>
       <p:sp>
         <p:nvSpPr>
@@ -7043,6 +7259,10 @@
             <a:prstDash val="solid"/>
           </a:ln>
         </p:spPr>
+        <p:txBody>
+          <a:bodyPr/>
+          <a:p/>
+        </p:txBody>
       </p:sp>
       <p:sp>
         <p:nvSpPr>
@@ -7107,6 +7327,10 @@
             <a:prstDash val="solid"/>
           </a:ln>
         </p:spPr>
+        <p:txBody>
+          <a:bodyPr/>
+          <a:p/>
+        </p:txBody>
       </p:sp>
       <p:sp>
         <p:nvSpPr>
@@ -7171,6 +7395,10 @@
             <a:prstDash val="solid"/>
           </a:ln>
         </p:spPr>
+        <p:txBody>
+          <a:bodyPr/>
+          <a:p/>
+        </p:txBody>
       </p:sp>
       <p:sp>
         <p:nvSpPr>
@@ -7237,6 +7465,10 @@
             <a:prstDash val="solid"/>
           </a:ln>
         </p:spPr>
+        <p:txBody>
+          <a:bodyPr/>
+          <a:p/>
+        </p:txBody>
       </p:sp>
       <p:sp>
         <p:nvSpPr>
@@ -7337,6 +7569,10 @@
             <a:prstDash val="solid"/>
           </a:ln>
         </p:spPr>
+        <p:txBody>
+          <a:bodyPr/>
+          <a:p/>
+        </p:txBody>
       </p:sp>
       <p:sp>
         <p:nvSpPr>
@@ -7366,6 +7602,10 @@
             <a:prstDash val="solid"/>
           </a:ln>
         </p:spPr>
+        <p:txBody>
+          <a:bodyPr/>
+          <a:p/>
+        </p:txBody>
       </p:sp>
       <p:sp>
         <p:nvSpPr>
@@ -7472,7 +7712,7 @@
             <a:r>
               <a:rPr lang="en-US" sz="950" dirty="0">
                 <a:solidFill>
-                  <a:srgbClr val="5E7680"/>
+                  <a:srgbClr val="425B65"/>
                 </a:solidFill>
                 <a:latin typeface="Calibri" pitchFamily="34" charset="0"/>
                 <a:ea typeface="Calibri" pitchFamily="34" charset="-122"/>
@@ -7510,6 +7750,10 @@
             <a:prstDash val="solid"/>
           </a:ln>
         </p:spPr>
+        <p:txBody>
+          <a:bodyPr/>
+          <a:p/>
+        </p:txBody>
       </p:sp>
       <p:sp>
         <p:nvSpPr>
@@ -7597,51 +7841,45 @@
         </p:nvSpPr>
         <p:spPr>
           <a:xfrm>
-            <a:off x="987552" y="3474720"/>
-            <a:ext cx="2029968" cy="658368"/>
-          </a:xfrm>
-          <a:prstGeom prst="rect">
-            <a:avLst/>
-          </a:prstGeom>
-          <a:noFill/>
-          <a:ln/>
-        </p:spPr>
-        <p:txBody>
-          <a:bodyPr wrap="square" lIns="0" tIns="0" rIns="0" bIns="0" rtlCol="0" anchor="ctr"/>
-          <a:lstStyle/>
-          <a:p>
-            <a:pPr algn="ctr" indent="0" marL="0">
-              <a:buNone/>
-            </a:pPr>
-            <a:r>
-              <a:rPr lang="en-US" sz="1350" dirty="0">
-                <a:solidFill>
-                  <a:srgbClr val="7FDBDA"/>
-                </a:solidFill>
-                <a:latin typeface="Calibri" pitchFamily="34" charset="0"/>
-                <a:ea typeface="Calibri" pitchFamily="34" charset="-122"/>
-                <a:cs typeface="Calibri" pitchFamily="34" charset="-120"/>
-              </a:rPr>
-              <a:t>2026-07-09 — 2026-07-16</a:t>
+            <a:off x="841248" y="3474720"/>
+            <a:ext cx="2340864" cy="658368"/>
+          </a:xfrm>
+          <a:prstGeom prst="rect">
+            <a:avLst/>
+          </a:prstGeom>
+          <a:noFill/>
+          <a:ln/>
+        </p:spPr>
+        <p:txBody>
+          <a:bodyPr wrap="square" lIns="0" tIns="0" rIns="0" bIns="0" rtlCol="0" anchor="ctr"/>
+          <a:lstStyle/>
+          <a:p>
+            <a:pPr algn="l" indent="0" marL="0">
+              <a:spcAft>
+                <a:spcPts val="500"/>
+              </a:spcAft>
+              <a:buNone/>
+            </a:pPr>
+            <a:r>
+              <a:rPr sz="1250">
+                <a:solidFill>
+                  <a:srgbClr val="BDEAE6"/>
+                </a:solidFill>
+              </a:rPr>
+              <a:t>2026-07-09 — 07-16</a:t>
             </a:r>
             <a:endParaRPr lang="en-US" sz="1350" dirty="0"/>
           </a:p>
           <a:p>
-            <a:pPr algn="ctr" indent="0" marL="0">
-              <a:buNone/>
-            </a:pPr>
-            <a:r>
-              <a:rPr lang="en-US" sz="1350" dirty="0">
-                <a:solidFill>
-                  <a:srgbClr val="7FDBDA"/>
-                </a:solidFill>
-                <a:latin typeface="Calibri" pitchFamily="34" charset="0"/>
-                <a:ea typeface="Calibri" pitchFamily="34" charset="-122"/>
-                <a:cs typeface="Calibri" pitchFamily="34" charset="-120"/>
+            <a:pPr algn="l"/>
+            <a:r>
+              <a:rPr sz="1250">
+                <a:solidFill>
+                  <a:srgbClr val="BDEAE6"/>
+                </a:solidFill>
               </a:rPr>
               <a:t>master 分支</a:t>
             </a:r>
-            <a:endParaRPr lang="en-US" sz="1350" dirty="0"/>
           </a:p>
         </p:txBody>
       </p:sp>
@@ -7671,6 +7909,10 @@
             <a:prstDash val="solid"/>
           </a:ln>
         </p:spPr>
+        <p:txBody>
+          <a:bodyPr/>
+          <a:p/>
+        </p:txBody>
       </p:sp>
       <p:sp>
         <p:nvSpPr>
@@ -7772,6 +8014,10 @@
             <a:prstDash val="solid"/>
           </a:ln>
         </p:spPr>
+        <p:txBody>
+          <a:bodyPr/>
+          <a:p/>
+        </p:txBody>
       </p:sp>
       <p:sp>
         <p:nvSpPr>
@@ -7797,6 +8043,10 @@
             <a:prstDash val="solid"/>
           </a:ln>
         </p:spPr>
+        <p:txBody>
+          <a:bodyPr/>
+          <a:p/>
+        </p:txBody>
       </p:sp>
       <p:sp>
         <p:nvSpPr>
@@ -7902,6 +8152,10 @@
             <a:prstDash val="solid"/>
           </a:ln>
         </p:spPr>
+        <p:txBody>
+          <a:bodyPr/>
+          <a:p/>
+        </p:txBody>
       </p:sp>
       <p:sp>
         <p:nvSpPr>
@@ -7966,6 +8220,10 @@
             <a:prstDash val="solid"/>
           </a:ln>
         </p:spPr>
+        <p:txBody>
+          <a:bodyPr/>
+          <a:p/>
+        </p:txBody>
       </p:sp>
       <p:sp>
         <p:nvSpPr>
@@ -8071,6 +8329,10 @@
             <a:prstDash val="solid"/>
           </a:ln>
         </p:spPr>
+        <p:txBody>
+          <a:bodyPr/>
+          <a:p/>
+        </p:txBody>
       </p:sp>
       <p:sp>
         <p:nvSpPr>
@@ -8135,6 +8397,10 @@
             <a:prstDash val="solid"/>
           </a:ln>
         </p:spPr>
+        <p:txBody>
+          <a:bodyPr/>
+          <a:p/>
+        </p:txBody>
       </p:sp>
       <p:sp>
         <p:nvSpPr>
@@ -8240,6 +8506,10 @@
             <a:prstDash val="solid"/>
           </a:ln>
         </p:spPr>
+        <p:txBody>
+          <a:bodyPr/>
+          <a:p/>
+        </p:txBody>
       </p:sp>
       <p:sp>
         <p:nvSpPr>
@@ -8304,6 +8574,10 @@
             <a:prstDash val="solid"/>
           </a:ln>
         </p:spPr>
+        <p:txBody>
+          <a:bodyPr/>
+          <a:p/>
+        </p:txBody>
       </p:sp>
       <p:sp>
         <p:nvSpPr>
@@ -8409,6 +8683,10 @@
             <a:prstDash val="solid"/>
           </a:ln>
         </p:spPr>
+        <p:txBody>
+          <a:bodyPr/>
+          <a:p/>
+        </p:txBody>
       </p:sp>
       <p:sp>
         <p:nvSpPr>
@@ -8475,6 +8753,10 @@
             <a:prstDash val="solid"/>
           </a:ln>
         </p:spPr>
+        <p:txBody>
+          <a:bodyPr/>
+          <a:p/>
+        </p:txBody>
       </p:sp>
       <p:sp>
         <p:nvSpPr>
@@ -8501,9 +8783,9 @@
               <a:buNone/>
             </a:pPr>
             <a:r>
-              <a:rPr lang="en-US" sz="1350" dirty="0">
-                <a:solidFill>
-                  <a:srgbClr val="8A4D20"/>
+              <a:rPr lang="en-US" sz="1400" dirty="0">
+                <a:solidFill>
+                  <a:srgbClr val="723A18"/>
                 </a:solidFill>
                 <a:latin typeface="Noto Sans CJK SC" pitchFamily="34" charset="0"/>
                 <a:ea typeface="Noto Sans CJK SC" pitchFamily="34" charset="-122"/>
@@ -8575,6 +8857,10 @@
             <a:prstDash val="solid"/>
           </a:ln>
         </p:spPr>
+        <p:txBody>
+          <a:bodyPr/>
+          <a:p/>
+        </p:txBody>
       </p:sp>
       <p:sp>
         <p:nvSpPr>
@@ -8604,6 +8890,10 @@
             <a:prstDash val="solid"/>
           </a:ln>
         </p:spPr>
+        <p:txBody>
+          <a:bodyPr/>
+          <a:p/>
+        </p:txBody>
       </p:sp>
       <p:sp>
         <p:nvSpPr>
@@ -8710,7 +9000,7 @@
             <a:r>
               <a:rPr lang="en-US" sz="950" dirty="0">
                 <a:solidFill>
-                  <a:srgbClr val="5E7680"/>
+                  <a:srgbClr val="425B65"/>
                 </a:solidFill>
                 <a:latin typeface="Calibri" pitchFamily="34" charset="0"/>
                 <a:ea typeface="Calibri" pitchFamily="34" charset="-122"/>
@@ -8755,6 +9045,10 @@
             </a:outerShdw>
           </a:effectLst>
         </p:spPr>
+        <p:txBody>
+          <a:bodyPr/>
+          <a:p/>
+        </p:txBody>
       </p:sp>
       <p:sp>
         <p:nvSpPr>
@@ -8780,6 +9074,10 @@
             <a:prstDash val="solid"/>
           </a:ln>
         </p:spPr>
+        <p:txBody>
+          <a:bodyPr/>
+          <a:p/>
+        </p:txBody>
       </p:sp>
       <p:sp>
         <p:nvSpPr>
@@ -8886,7 +9184,7 @@
             <a:r>
               <a:rPr lang="en-US" sz="1050" dirty="0">
                 <a:solidFill>
-                  <a:srgbClr val="5E7680"/>
+                  <a:srgbClr val="425B65"/>
                 </a:solidFill>
                 <a:latin typeface="Noto Sans CJK SC" pitchFamily="34" charset="0"/>
                 <a:ea typeface="Noto Sans CJK SC" pitchFamily="34" charset="-122"/>
@@ -8931,6 +9229,10 @@
             </a:outerShdw>
           </a:effectLst>
         </p:spPr>
+        <p:txBody>
+          <a:bodyPr/>
+          <a:p/>
+        </p:txBody>
       </p:sp>
       <p:sp>
         <p:nvSpPr>
@@ -8956,6 +9258,10 @@
             <a:prstDash val="solid"/>
           </a:ln>
         </p:spPr>
+        <p:txBody>
+          <a:bodyPr/>
+          <a:p/>
+        </p:txBody>
       </p:sp>
       <p:sp>
         <p:nvSpPr>
@@ -9062,7 +9368,7 @@
             <a:r>
               <a:rPr lang="en-US" sz="1050" dirty="0">
                 <a:solidFill>
-                  <a:srgbClr val="5E7680"/>
+                  <a:srgbClr val="425B65"/>
                 </a:solidFill>
                 <a:latin typeface="Noto Sans CJK SC" pitchFamily="34" charset="0"/>
                 <a:ea typeface="Noto Sans CJK SC" pitchFamily="34" charset="-122"/>
@@ -9107,6 +9413,10 @@
             </a:outerShdw>
           </a:effectLst>
         </p:spPr>
+        <p:txBody>
+          <a:bodyPr/>
+          <a:p/>
+        </p:txBody>
       </p:sp>
       <p:sp>
         <p:nvSpPr>
@@ -9132,6 +9442,10 @@
             <a:prstDash val="solid"/>
           </a:ln>
         </p:spPr>
+        <p:txBody>
+          <a:bodyPr/>
+          <a:p/>
+        </p:txBody>
       </p:sp>
       <p:sp>
         <p:nvSpPr>
@@ -9238,7 +9552,7 @@
             <a:r>
               <a:rPr lang="en-US" sz="1050" dirty="0">
                 <a:solidFill>
-                  <a:srgbClr val="5E7680"/>
+                  <a:srgbClr val="425B65"/>
                 </a:solidFill>
                 <a:latin typeface="Noto Sans CJK SC" pitchFamily="34" charset="0"/>
                 <a:ea typeface="Noto Sans CJK SC" pitchFamily="34" charset="-122"/>
@@ -9283,6 +9597,10 @@
             </a:outerShdw>
           </a:effectLst>
         </p:spPr>
+        <p:txBody>
+          <a:bodyPr/>
+          <a:p/>
+        </p:txBody>
       </p:sp>
       <p:sp>
         <p:nvSpPr>
@@ -9308,6 +9626,10 @@
             <a:prstDash val="solid"/>
           </a:ln>
         </p:spPr>
+        <p:txBody>
+          <a:bodyPr/>
+          <a:p/>
+        </p:txBody>
       </p:sp>
       <p:sp>
         <p:nvSpPr>
@@ -9414,7 +9736,7 @@
             <a:r>
               <a:rPr lang="en-US" sz="1050" dirty="0">
                 <a:solidFill>
-                  <a:srgbClr val="5E7680"/>
+                  <a:srgbClr val="425B65"/>
                 </a:solidFill>
                 <a:latin typeface="Noto Sans CJK SC" pitchFamily="34" charset="0"/>
                 <a:ea typeface="Noto Sans CJK SC" pitchFamily="34" charset="-122"/>
@@ -9498,6 +9820,10 @@
             </a:outerShdw>
           </a:effectLst>
         </p:spPr>
+        <p:txBody>
+          <a:bodyPr/>
+          <a:p/>
+        </p:txBody>
       </p:sp>
       <p:sp>
         <p:nvSpPr>
@@ -9604,7 +9930,7 @@
             <a:r>
               <a:rPr lang="en-US" sz="1150" dirty="0">
                 <a:solidFill>
-                  <a:srgbClr val="5E7680"/>
+                  <a:srgbClr val="425B65"/>
                 </a:solidFill>
                 <a:latin typeface="Noto Sans CJK SC" pitchFamily="34" charset="0"/>
                 <a:ea typeface="Noto Sans CJK SC" pitchFamily="34" charset="-122"/>
@@ -9640,6 +9966,10 @@
             <a:prstDash val="solid"/>
           </a:ln>
         </p:spPr>
+        <p:txBody>
+          <a:bodyPr/>
+          <a:p/>
+        </p:txBody>
       </p:sp>
       <p:sp>
         <p:nvSpPr>
@@ -9674,6 +10004,10 @@
             </a:outerShdw>
           </a:effectLst>
         </p:spPr>
+        <p:txBody>
+          <a:bodyPr/>
+          <a:p/>
+        </p:txBody>
       </p:sp>
       <p:sp>
         <p:nvSpPr>
@@ -9780,7 +10114,7 @@
             <a:r>
               <a:rPr lang="en-US" sz="1150" dirty="0">
                 <a:solidFill>
-                  <a:srgbClr val="5E7680"/>
+                  <a:srgbClr val="425B65"/>
                 </a:solidFill>
                 <a:latin typeface="Noto Sans CJK SC" pitchFamily="34" charset="0"/>
                 <a:ea typeface="Noto Sans CJK SC" pitchFamily="34" charset="-122"/>
@@ -9816,6 +10150,10 @@
             <a:prstDash val="solid"/>
           </a:ln>
         </p:spPr>
+        <p:txBody>
+          <a:bodyPr/>
+          <a:p/>
+        </p:txBody>
       </p:sp>
       <p:sp>
         <p:nvSpPr>
@@ -9850,6 +10188,10 @@
             </a:outerShdw>
           </a:effectLst>
         </p:spPr>
+        <p:txBody>
+          <a:bodyPr/>
+          <a:p/>
+        </p:txBody>
       </p:sp>
       <p:sp>
         <p:nvSpPr>
@@ -9956,7 +10298,7 @@
             <a:r>
               <a:rPr lang="en-US" sz="1150" dirty="0">
                 <a:solidFill>
-                  <a:srgbClr val="5E7680"/>
+                  <a:srgbClr val="425B65"/>
                 </a:solidFill>
                 <a:latin typeface="Noto Sans CJK SC" pitchFamily="34" charset="0"/>
                 <a:ea typeface="Noto Sans CJK SC" pitchFamily="34" charset="-122"/>
@@ -9992,6 +10334,10 @@
             <a:prstDash val="solid"/>
           </a:ln>
         </p:spPr>
+        <p:txBody>
+          <a:bodyPr/>
+          <a:p/>
+        </p:txBody>
       </p:sp>
       <p:sp>
         <p:nvSpPr>
@@ -10026,6 +10372,10 @@
             </a:outerShdw>
           </a:effectLst>
         </p:spPr>
+        <p:txBody>
+          <a:bodyPr/>
+          <a:p/>
+        </p:txBody>
       </p:sp>
       <p:sp>
         <p:nvSpPr>
@@ -10132,7 +10482,7 @@
             <a:r>
               <a:rPr lang="en-US" sz="1150" dirty="0">
                 <a:solidFill>
-                  <a:srgbClr val="5E7680"/>
+                  <a:srgbClr val="425B65"/>
                 </a:solidFill>
                 <a:latin typeface="Noto Sans CJK SC" pitchFamily="34" charset="0"/>
                 <a:ea typeface="Noto Sans CJK SC" pitchFamily="34" charset="-122"/>
@@ -10170,6 +10520,10 @@
             <a:prstDash val="solid"/>
           </a:ln>
         </p:spPr>
+        <p:txBody>
+          <a:bodyPr/>
+          <a:p/>
+        </p:txBody>
       </p:sp>
       <p:sp>
         <p:nvSpPr>
@@ -10309,6 +10663,10 @@
             <a:prstDash val="solid"/>
           </a:ln>
         </p:spPr>
+        <p:txBody>
+          <a:bodyPr/>
+          <a:p/>
+        </p:txBody>
       </p:sp>
       <p:sp>
         <p:nvSpPr>
@@ -10338,6 +10696,10 @@
             <a:prstDash val="solid"/>
           </a:ln>
         </p:spPr>
+        <p:txBody>
+          <a:bodyPr/>
+          <a:p/>
+        </p:txBody>
       </p:sp>
       <p:sp>
         <p:nvSpPr>
@@ -10444,7 +10806,7 @@
             <a:r>
               <a:rPr lang="en-US" sz="950" dirty="0">
                 <a:solidFill>
-                  <a:srgbClr val="5E7680"/>
+                  <a:srgbClr val="425B65"/>
                 </a:solidFill>
                 <a:latin typeface="Calibri" pitchFamily="34" charset="0"/>
                 <a:ea typeface="Calibri" pitchFamily="34" charset="-122"/>
@@ -10489,6 +10851,10 @@
             </a:outerShdw>
           </a:effectLst>
         </p:spPr>
+        <p:txBody>
+          <a:bodyPr/>
+          <a:p/>
+        </p:txBody>
       </p:sp>
       <p:sp>
         <p:nvSpPr>
@@ -10514,6 +10880,10 @@
             <a:prstDash val="solid"/>
           </a:ln>
         </p:spPr>
+        <p:txBody>
+          <a:bodyPr/>
+          <a:p/>
+        </p:txBody>
       </p:sp>
       <p:sp>
         <p:nvSpPr>
@@ -10622,7 +10992,7 @@
             <a:r>
               <a:rPr lang="en-US" sz="1400" dirty="0">
                 <a:solidFill>
-                  <a:srgbClr val="5E7680"/>
+                  <a:srgbClr val="425B65"/>
                 </a:solidFill>
                 <a:latin typeface="Noto Sans CJK SC" pitchFamily="34" charset="0"/>
                 <a:ea typeface="Noto Sans CJK SC" pitchFamily="34" charset="-122"/>
@@ -10667,6 +11037,10 @@
             </a:outerShdw>
           </a:effectLst>
         </p:spPr>
+        <p:txBody>
+          <a:bodyPr/>
+          <a:p/>
+        </p:txBody>
       </p:sp>
       <p:sp>
         <p:nvSpPr>
@@ -10692,6 +11066,10 @@
             <a:prstDash val="solid"/>
           </a:ln>
         </p:spPr>
+        <p:txBody>
+          <a:bodyPr/>
+          <a:p/>
+        </p:txBody>
       </p:sp>
       <p:sp>
         <p:nvSpPr>
@@ -10800,7 +11178,7 @@
             <a:r>
               <a:rPr lang="en-US" sz="1400" dirty="0">
                 <a:solidFill>
-                  <a:srgbClr val="5E7680"/>
+                  <a:srgbClr val="425B65"/>
                 </a:solidFill>
                 <a:latin typeface="Noto Sans CJK SC" pitchFamily="34" charset="0"/>
                 <a:ea typeface="Noto Sans CJK SC" pitchFamily="34" charset="-122"/>
@@ -10845,6 +11223,10 @@
             </a:outerShdw>
           </a:effectLst>
         </p:spPr>
+        <p:txBody>
+          <a:bodyPr/>
+          <a:p/>
+        </p:txBody>
       </p:sp>
       <p:sp>
         <p:nvSpPr>
@@ -10870,6 +11252,10 @@
             <a:prstDash val="solid"/>
           </a:ln>
         </p:spPr>
+        <p:txBody>
+          <a:bodyPr/>
+          <a:p/>
+        </p:txBody>
       </p:sp>
       <p:sp>
         <p:nvSpPr>
@@ -10978,7 +11364,7 @@
             <a:r>
               <a:rPr lang="en-US" sz="1400" dirty="0">
                 <a:solidFill>
-                  <a:srgbClr val="5E7680"/>
+                  <a:srgbClr val="425B65"/>
                 </a:solidFill>
                 <a:latin typeface="Noto Sans CJK SC" pitchFamily="34" charset="0"/>
                 <a:ea typeface="Noto Sans CJK SC" pitchFamily="34" charset="-122"/>
@@ -11023,6 +11409,10 @@
             </a:outerShdw>
           </a:effectLst>
         </p:spPr>
+        <p:txBody>
+          <a:bodyPr/>
+          <a:p/>
+        </p:txBody>
       </p:sp>
       <p:sp>
         <p:nvSpPr>
@@ -11048,6 +11438,10 @@
             <a:prstDash val="solid"/>
           </a:ln>
         </p:spPr>
+        <p:txBody>
+          <a:bodyPr/>
+          <a:p/>
+        </p:txBody>
       </p:sp>
       <p:sp>
         <p:nvSpPr>
@@ -11156,7 +11550,7 @@
             <a:r>
               <a:rPr lang="en-US" sz="1400" dirty="0">
                 <a:solidFill>
-                  <a:srgbClr val="5E7680"/>
+                  <a:srgbClr val="425B65"/>
                 </a:solidFill>
                 <a:latin typeface="Noto Sans CJK SC" pitchFamily="34" charset="0"/>
                 <a:ea typeface="Noto Sans CJK SC" pitchFamily="34" charset="-122"/>
@@ -11194,6 +11588,10 @@
             <a:prstDash val="solid"/>
           </a:ln>
         </p:spPr>
+        <p:txBody>
+          <a:bodyPr/>
+          <a:p/>
+        </p:txBody>
       </p:sp>
       <p:sp>
         <p:nvSpPr>
@@ -11294,6 +11692,10 @@
             <a:prstDash val="solid"/>
           </a:ln>
         </p:spPr>
+        <p:txBody>
+          <a:bodyPr/>
+          <a:p/>
+        </p:txBody>
       </p:sp>
       <p:sp>
         <p:nvSpPr>
@@ -11323,6 +11725,10 @@
             <a:prstDash val="solid"/>
           </a:ln>
         </p:spPr>
+        <p:txBody>
+          <a:bodyPr/>
+          <a:p/>
+        </p:txBody>
       </p:sp>
       <p:sp>
         <p:nvSpPr>
@@ -11429,7 +11835,7 @@
             <a:r>
               <a:rPr lang="en-US" sz="950" dirty="0">
                 <a:solidFill>
-                  <a:srgbClr val="5E7680"/>
+                  <a:srgbClr val="425B65"/>
                 </a:solidFill>
                 <a:latin typeface="Calibri" pitchFamily="34" charset="0"/>
                 <a:ea typeface="Calibri" pitchFamily="34" charset="-122"/>
@@ -11474,6 +11880,10 @@
             </a:outerShdw>
           </a:effectLst>
         </p:spPr>
+        <p:txBody>
+          <a:bodyPr/>
+          <a:p/>
+        </p:txBody>
       </p:sp>
       <p:sp>
         <p:nvSpPr>
@@ -11501,6 +11911,10 @@
             <a:prstDash val="solid"/>
           </a:ln>
         </p:spPr>
+        <p:txBody>
+          <a:bodyPr/>
+          <a:p/>
+        </p:txBody>
       </p:sp>
       <p:sp>
         <p:nvSpPr>
@@ -11604,6 +12018,10 @@
             <a:prstDash val="solid"/>
           </a:ln>
         </p:spPr>
+        <p:txBody>
+          <a:bodyPr/>
+          <a:p/>
+        </p:txBody>
       </p:sp>
       <p:sp>
         <p:nvSpPr>
@@ -11671,7 +12089,7 @@
             <a:r>
               <a:rPr lang="en-US" sz="1400" dirty="0">
                 <a:solidFill>
-                  <a:srgbClr val="5E7680"/>
+                  <a:srgbClr val="425B65"/>
                 </a:solidFill>
                 <a:latin typeface="Noto Sans CJK SC" pitchFamily="34" charset="0"/>
                 <a:ea typeface="Noto Sans CJK SC" pitchFamily="34" charset="-122"/>
@@ -11707,6 +12125,10 @@
             <a:prstDash val="solid"/>
           </a:ln>
         </p:spPr>
+        <p:txBody>
+          <a:bodyPr/>
+          <a:p/>
+        </p:txBody>
       </p:sp>
       <p:sp>
         <p:nvSpPr>
@@ -11774,7 +12196,7 @@
             <a:r>
               <a:rPr lang="en-US" sz="1400" dirty="0">
                 <a:solidFill>
-                  <a:srgbClr val="5E7680"/>
+                  <a:srgbClr val="425B65"/>
                 </a:solidFill>
                 <a:latin typeface="Noto Sans CJK SC" pitchFamily="34" charset="0"/>
                 <a:ea typeface="Noto Sans CJK SC" pitchFamily="34" charset="-122"/>
@@ -11810,6 +12232,10 @@
             <a:prstDash val="solid"/>
           </a:ln>
         </p:spPr>
+        <p:txBody>
+          <a:bodyPr/>
+          <a:p/>
+        </p:txBody>
       </p:sp>
       <p:sp>
         <p:nvSpPr>
@@ -11877,7 +12303,7 @@
             <a:r>
               <a:rPr lang="en-US" sz="1400" dirty="0">
                 <a:solidFill>
-                  <a:srgbClr val="5E7680"/>
+                  <a:srgbClr val="425B65"/>
                 </a:solidFill>
                 <a:latin typeface="Noto Sans CJK SC" pitchFamily="34" charset="0"/>
                 <a:ea typeface="Noto Sans CJK SC" pitchFamily="34" charset="-122"/>
@@ -11913,6 +12339,10 @@
             <a:prstDash val="solid"/>
           </a:ln>
         </p:spPr>
+        <p:txBody>
+          <a:bodyPr/>
+          <a:p/>
+        </p:txBody>
       </p:sp>
       <p:sp>
         <p:nvSpPr>
@@ -11947,6 +12377,10 @@
             </a:outerShdw>
           </a:effectLst>
         </p:spPr>
+        <p:txBody>
+          <a:bodyPr/>
+          <a:p/>
+        </p:txBody>
       </p:sp>
       <p:sp>
         <p:nvSpPr>
@@ -11974,6 +12408,10 @@
             <a:prstDash val="solid"/>
           </a:ln>
         </p:spPr>
+        <p:txBody>
+          <a:bodyPr/>
+          <a:p/>
+        </p:txBody>
       </p:sp>
       <p:sp>
         <p:nvSpPr>
@@ -12077,6 +12515,10 @@
             <a:prstDash val="solid"/>
           </a:ln>
         </p:spPr>
+        <p:txBody>
+          <a:bodyPr/>
+          <a:p/>
+        </p:txBody>
       </p:sp>
       <p:sp>
         <p:nvSpPr>
@@ -12144,7 +12586,7 @@
             <a:r>
               <a:rPr lang="en-US" sz="1400" dirty="0">
                 <a:solidFill>
-                  <a:srgbClr val="5E7680"/>
+                  <a:srgbClr val="425B65"/>
                 </a:solidFill>
                 <a:latin typeface="Noto Sans CJK SC" pitchFamily="34" charset="0"/>
                 <a:ea typeface="Noto Sans CJK SC" pitchFamily="34" charset="-122"/>
@@ -12180,6 +12622,10 @@
             <a:prstDash val="solid"/>
           </a:ln>
         </p:spPr>
+        <p:txBody>
+          <a:bodyPr/>
+          <a:p/>
+        </p:txBody>
       </p:sp>
       <p:sp>
         <p:nvSpPr>
@@ -12247,7 +12693,7 @@
             <a:r>
               <a:rPr lang="en-US" sz="1400" dirty="0">
                 <a:solidFill>
-                  <a:srgbClr val="5E7680"/>
+                  <a:srgbClr val="425B65"/>
                 </a:solidFill>
                 <a:latin typeface="Noto Sans CJK SC" pitchFamily="34" charset="0"/>
                 <a:ea typeface="Noto Sans CJK SC" pitchFamily="34" charset="-122"/>
@@ -12283,6 +12729,10 @@
             <a:prstDash val="solid"/>
           </a:ln>
         </p:spPr>
+        <p:txBody>
+          <a:bodyPr/>
+          <a:p/>
+        </p:txBody>
       </p:sp>
       <p:sp>
         <p:nvSpPr>
@@ -12350,7 +12800,7 @@
             <a:r>
               <a:rPr lang="en-US" sz="1400" dirty="0">
                 <a:solidFill>
-                  <a:srgbClr val="5E7680"/>
+                  <a:srgbClr val="425B65"/>
                 </a:solidFill>
                 <a:latin typeface="Noto Sans CJK SC" pitchFamily="34" charset="0"/>
                 <a:ea typeface="Noto Sans CJK SC" pitchFamily="34" charset="-122"/>
@@ -12386,6 +12836,10 @@
             <a:prstDash val="solid"/>
           </a:ln>
         </p:spPr>
+        <p:txBody>
+          <a:bodyPr/>
+          <a:p/>
+        </p:txBody>
       </p:sp>
       <p:sp>
         <p:nvSpPr>
@@ -12420,6 +12874,10 @@
             </a:outerShdw>
           </a:effectLst>
         </p:spPr>
+        <p:txBody>
+          <a:bodyPr/>
+          <a:p/>
+        </p:txBody>
       </p:sp>
       <p:sp>
         <p:nvSpPr>
@@ -12447,6 +12905,10 @@
             <a:prstDash val="solid"/>
           </a:ln>
         </p:spPr>
+        <p:txBody>
+          <a:bodyPr/>
+          <a:p/>
+        </p:txBody>
       </p:sp>
       <p:sp>
         <p:nvSpPr>
@@ -12550,6 +13012,10 @@
             <a:prstDash val="solid"/>
           </a:ln>
         </p:spPr>
+        <p:txBody>
+          <a:bodyPr/>
+          <a:p/>
+        </p:txBody>
       </p:sp>
       <p:sp>
         <p:nvSpPr>
@@ -12617,7 +13083,7 @@
             <a:r>
               <a:rPr lang="en-US" sz="1400" dirty="0">
                 <a:solidFill>
-                  <a:srgbClr val="5E7680"/>
+                  <a:srgbClr val="425B65"/>
                 </a:solidFill>
                 <a:latin typeface="Noto Sans CJK SC" pitchFamily="34" charset="0"/>
                 <a:ea typeface="Noto Sans CJK SC" pitchFamily="34" charset="-122"/>
@@ -12653,6 +13119,10 @@
             <a:prstDash val="solid"/>
           </a:ln>
         </p:spPr>
+        <p:txBody>
+          <a:bodyPr/>
+          <a:p/>
+        </p:txBody>
       </p:sp>
       <p:sp>
         <p:nvSpPr>
@@ -12720,7 +13190,7 @@
             <a:r>
               <a:rPr lang="en-US" sz="1400" dirty="0">
                 <a:solidFill>
-                  <a:srgbClr val="5E7680"/>
+                  <a:srgbClr val="425B65"/>
                 </a:solidFill>
                 <a:latin typeface="Noto Sans CJK SC" pitchFamily="34" charset="0"/>
                 <a:ea typeface="Noto Sans CJK SC" pitchFamily="34" charset="-122"/>
@@ -12756,6 +13226,10 @@
             <a:prstDash val="solid"/>
           </a:ln>
         </p:spPr>
+        <p:txBody>
+          <a:bodyPr/>
+          <a:p/>
+        </p:txBody>
       </p:sp>
       <p:sp>
         <p:nvSpPr>
@@ -12823,7 +13297,7 @@
             <a:r>
               <a:rPr lang="en-US" sz="1400" dirty="0">
                 <a:solidFill>
-                  <a:srgbClr val="5E7680"/>
+                  <a:srgbClr val="425B65"/>
                 </a:solidFill>
                 <a:latin typeface="Noto Sans CJK SC" pitchFamily="34" charset="0"/>
                 <a:ea typeface="Noto Sans CJK SC" pitchFamily="34" charset="-122"/>
@@ -12859,6 +13333,10 @@
             <a:prstDash val="solid"/>
           </a:ln>
         </p:spPr>
+        <p:txBody>
+          <a:bodyPr/>
+          <a:p/>
+        </p:txBody>
       </p:sp>
     </p:spTree>
   </p:cSld>

</xml_diff>